<commit_message>
Final commit for the internship ig; added the product demo ppt along with the tech explaination one; huge thanks to our mentor for thier guidance and to the infosys springboard team for thier opportunity
</commit_message>
<xml_diff>
--- a/docs/Presentation1.pptx
+++ b/docs/Presentation1.pptx
@@ -3241,30 +3241,6 @@
         <p:nvPr/>
       </p:nvGrpSpPr>
       <p:grpSpPr/>
-      <p:pic>
-        <p:nvPicPr>
-          <p:cNvPr id="2" name="Picture 1" descr="clear face skin example"/>
-          <p:cNvPicPr>
-            <a:picLocks noChangeAspect="1"/>
-          </p:cNvPicPr>
-          <p:nvPr/>
-        </p:nvPicPr>
-        <p:blipFill>
-          <a:blip r:embed="rId1"/>
-          <a:stretch>
-            <a:fillRect/>
-          </a:stretch>
-        </p:blipFill>
-        <p:spPr>
-          <a:xfrm>
-            <a:off x="102870" y="1805940"/>
-            <a:ext cx="3086100" cy="3726815"/>
-          </a:xfrm>
-          <a:prstGeom prst="rect">
-            <a:avLst/>
-          </a:prstGeom>
-        </p:spPr>
-      </p:pic>
       <p:sp>
         <p:nvSpPr>
           <p:cNvPr id="4" name="Rounded Rectangle 3"/>
@@ -3308,54 +3284,6 @@
           </a:p>
         </p:txBody>
       </p:sp>
-      <p:pic>
-        <p:nvPicPr>
-          <p:cNvPr id="5" name="Picture 4" descr="annotated (3)"/>
-          <p:cNvPicPr>
-            <a:picLocks noChangeAspect="1"/>
-          </p:cNvPicPr>
-          <p:nvPr/>
-        </p:nvPicPr>
-        <p:blipFill>
-          <a:blip r:embed="rId2"/>
-          <a:stretch>
-            <a:fillRect/>
-          </a:stretch>
-        </p:blipFill>
-        <p:spPr>
-          <a:xfrm>
-            <a:off x="4329430" y="1805940"/>
-            <a:ext cx="2719705" cy="3727450"/>
-          </a:xfrm>
-          <a:prstGeom prst="rect">
-            <a:avLst/>
-          </a:prstGeom>
-        </p:spPr>
-      </p:pic>
-      <p:pic>
-        <p:nvPicPr>
-          <p:cNvPr id="6" name="Picture 5" descr="annotated (4)"/>
-          <p:cNvPicPr>
-            <a:picLocks noChangeAspect="1"/>
-          </p:cNvPicPr>
-          <p:nvPr/>
-        </p:nvPicPr>
-        <p:blipFill>
-          <a:blip r:embed="rId3"/>
-          <a:stretch>
-            <a:fillRect/>
-          </a:stretch>
-        </p:blipFill>
-        <p:spPr>
-          <a:xfrm>
-            <a:off x="8478520" y="1897380"/>
-            <a:ext cx="3086100" cy="3635375"/>
-          </a:xfrm>
-          <a:prstGeom prst="rect">
-            <a:avLst/>
-          </a:prstGeom>
-        </p:spPr>
-      </p:pic>
     </p:spTree>
   </p:cSld>
   <p:clrMapOvr>

</xml_diff>